<commit_message>
13th commit: Added a few more slides on the database stucture in the PowerPoint
</commit_message>
<xml_diff>
--- a/St10437348_Prog6212_SummativePP.pptx
+++ b/St10437348_Prog6212_SummativePP.pptx
@@ -21,25 +21,27 @@
     <p:sldId id="269" r:id="rId15"/>
     <p:sldId id="270" r:id="rId16"/>
     <p:sldId id="271" r:id="rId17"/>
-    <p:sldId id="272" r:id="rId18"/>
-    <p:sldId id="273" r:id="rId19"/>
-    <p:sldId id="274" r:id="rId20"/>
-    <p:sldId id="275" r:id="rId21"/>
+    <p:sldId id="277" r:id="rId18"/>
+    <p:sldId id="276" r:id="rId19"/>
+    <p:sldId id="272" r:id="rId20"/>
+    <p:sldId id="273" r:id="rId21"/>
+    <p:sldId id="274" r:id="rId22"/>
+    <p:sldId id="275" r:id="rId23"/>
   </p:sldIdLst>
   <p:sldSz cx="18288000" cy="10287000"/>
   <p:notesSz cx="6858000" cy="9144000"/>
   <p:embeddedFontLst>
     <p:embeddedFont>
       <p:font typeface="Alexandria Bold" panose="020B0604020202020204" charset="-78"/>
-      <p:regular r:id="rId22"/>
+      <p:regular r:id="rId24"/>
     </p:embeddedFont>
     <p:embeddedFont>
       <p:font typeface="Garet" panose="020B0604020202020204" charset="0"/>
-      <p:regular r:id="rId23"/>
+      <p:regular r:id="rId25"/>
     </p:embeddedFont>
     <p:embeddedFont>
       <p:font typeface="Garet Bold" panose="020B0604020202020204" charset="0"/>
-      <p:regular r:id="rId24"/>
+      <p:regular r:id="rId26"/>
     </p:embeddedFont>
   </p:embeddedFontLst>
   <p:defaultTextStyle>
@@ -6506,7 +6508,13 @@
     </p:bg>
     <p:spTree>
       <p:nvGrpSpPr>
-        <p:cNvPr id="1" name=""/>
+        <p:cNvPr id="1" name="">
+          <a:extLst>
+            <a:ext uri="{FF2B5EF4-FFF2-40B4-BE49-F238E27FC236}">
+              <a16:creationId xmlns:a16="http://schemas.microsoft.com/office/drawing/2014/main" id="{7EBFD739-3B14-F22E-2149-33A244B1F27C}"/>
+            </a:ext>
+          </a:extLst>
+        </p:cNvPr>
         <p:cNvGrpSpPr/>
         <p:nvPr/>
       </p:nvGrpSpPr>
@@ -6520,7 +6528,13 @@
       </p:grpSpPr>
       <p:sp>
         <p:nvSpPr>
-          <p:cNvPr id="2" name="Freeform 2"/>
+          <p:cNvPr id="2" name="Freeform 2">
+            <a:extLst>
+              <a:ext uri="{FF2B5EF4-FFF2-40B4-BE49-F238E27FC236}">
+                <a16:creationId xmlns:a16="http://schemas.microsoft.com/office/drawing/2014/main" id="{0D24035D-ACBF-E51A-8A36-E618070E1B99}"/>
+              </a:ext>
+            </a:extLst>
+          </p:cNvPr>
           <p:cNvSpPr/>
           <p:nvPr/>
         </p:nvSpPr>
@@ -6579,7 +6593,13 @@
       </p:sp>
       <p:sp>
         <p:nvSpPr>
-          <p:cNvPr id="3" name="Freeform 3"/>
+          <p:cNvPr id="3" name="Freeform 3">
+            <a:extLst>
+              <a:ext uri="{FF2B5EF4-FFF2-40B4-BE49-F238E27FC236}">
+                <a16:creationId xmlns:a16="http://schemas.microsoft.com/office/drawing/2014/main" id="{526FCD47-4847-28AD-C7E3-DCE7D9D84BEC}"/>
+              </a:ext>
+            </a:extLst>
+          </p:cNvPr>
           <p:cNvSpPr/>
           <p:nvPr/>
         </p:nvSpPr>
@@ -6638,7 +6658,13 @@
       </p:sp>
       <p:sp>
         <p:nvSpPr>
-          <p:cNvPr id="4" name="AutoShape 4"/>
+          <p:cNvPr id="4" name="AutoShape 4">
+            <a:extLst>
+              <a:ext uri="{FF2B5EF4-FFF2-40B4-BE49-F238E27FC236}">
+                <a16:creationId xmlns:a16="http://schemas.microsoft.com/office/drawing/2014/main" id="{0122DCCD-BC55-6F54-5839-6BE9340DD086}"/>
+              </a:ext>
+            </a:extLst>
+          </p:cNvPr>
           <p:cNvSpPr/>
           <p:nvPr/>
         </p:nvSpPr>
@@ -6669,14 +6695,20 @@
       </p:sp>
       <p:sp>
         <p:nvSpPr>
-          <p:cNvPr id="5" name="TextBox 5"/>
+          <p:cNvPr id="5" name="TextBox 5">
+            <a:extLst>
+              <a:ext uri="{FF2B5EF4-FFF2-40B4-BE49-F238E27FC236}">
+                <a16:creationId xmlns:a16="http://schemas.microsoft.com/office/drawing/2014/main" id="{1A075E30-5F77-03DF-E1BC-A7F382AA7227}"/>
+              </a:ext>
+            </a:extLst>
+          </p:cNvPr>
           <p:cNvSpPr txBox="1"/>
           <p:nvPr/>
         </p:nvSpPr>
         <p:spPr>
           <a:xfrm>
-            <a:off x="2831550" y="550652"/>
-            <a:ext cx="12624901" cy="1268973"/>
+            <a:off x="3876712" y="-152400"/>
+            <a:ext cx="12038072" cy="1392492"/>
           </a:xfrm>
           <a:prstGeom prst="rect">
             <a:avLst/>
@@ -6690,11 +6722,11 @@
           <a:p>
             <a:pPr algn="ctr">
               <a:lnSpc>
-                <a:spcPts val="10396"/>
+                <a:spcPts val="11448"/>
               </a:lnSpc>
             </a:pPr>
             <a:r>
-              <a:rPr lang="en-US" sz="7425" b="1">
+              <a:rPr lang="en-US" sz="8177" b="1">
                 <a:solidFill>
                   <a:srgbClr val="3F3D3E"/>
                 </a:solidFill>
@@ -6703,162 +6735,27 @@
                 <a:cs typeface="Alexandria Bold"/>
                 <a:sym typeface="Alexandria Bold"/>
               </a:rPr>
-              <a:t>Demonstration Summary</a:t>
-            </a:r>
-          </a:p>
-        </p:txBody>
-      </p:sp>
-      <p:sp>
-        <p:nvSpPr>
-          <p:cNvPr id="6" name="TextBox 6"/>
+              <a:t>Database Structure</a:t>
+            </a:r>
+          </a:p>
+        </p:txBody>
+      </p:sp>
+      <p:sp>
+        <p:nvSpPr>
+          <p:cNvPr id="6" name="TextBox 6">
+            <a:extLst>
+              <a:ext uri="{FF2B5EF4-FFF2-40B4-BE49-F238E27FC236}">
+                <a16:creationId xmlns:a16="http://schemas.microsoft.com/office/drawing/2014/main" id="{E41E7D7F-46A3-CEE9-9A94-784AD79E49BC}"/>
+              </a:ext>
+            </a:extLst>
+          </p:cNvPr>
           <p:cNvSpPr txBox="1"/>
           <p:nvPr/>
         </p:nvSpPr>
         <p:spPr>
           <a:xfrm>
-            <a:off x="3205732" y="3024506"/>
-            <a:ext cx="11876536" cy="3469796"/>
-          </a:xfrm>
-          <a:prstGeom prst="rect">
-            <a:avLst/>
-          </a:prstGeom>
-        </p:spPr>
-        <p:txBody>
-          <a:bodyPr lIns="0" tIns="0" rIns="0" bIns="0" rtlCol="0" anchor="t">
-            <a:spAutoFit/>
-          </a:bodyPr>
-          <a:lstStyle/>
-          <a:p>
-            <a:pPr algn="l">
-              <a:lnSpc>
-                <a:spcPts val="4576"/>
-              </a:lnSpc>
-            </a:pPr>
-            <a:r>
-              <a:rPr lang="en-US" sz="3268">
-                <a:solidFill>
-                  <a:srgbClr val="545454"/>
-                </a:solidFill>
-                <a:latin typeface="Garet"/>
-                <a:ea typeface="Garet"/>
-                <a:cs typeface="Garet"/>
-                <a:sym typeface="Garet"/>
-              </a:rPr>
-              <a:t>Summaries of key workflows:</a:t>
-            </a:r>
-          </a:p>
-          <a:p>
-            <a:pPr marL="705747" lvl="1" indent="-352873" algn="l">
-              <a:lnSpc>
-                <a:spcPts val="4576"/>
-              </a:lnSpc>
-              <a:buFont typeface="Arial"/>
-              <a:buChar char="•"/>
-            </a:pPr>
-            <a:r>
-              <a:rPr lang="en-US" sz="3268">
-                <a:solidFill>
-                  <a:srgbClr val="545454"/>
-                </a:solidFill>
-                <a:latin typeface="Garet"/>
-                <a:ea typeface="Garet"/>
-                <a:cs typeface="Garet"/>
-                <a:sym typeface="Garet"/>
-              </a:rPr>
-              <a:t>Lecturer submits claim</a:t>
-            </a:r>
-          </a:p>
-          <a:p>
-            <a:pPr marL="705747" lvl="1" indent="-352873" algn="l">
-              <a:lnSpc>
-                <a:spcPts val="4576"/>
-              </a:lnSpc>
-              <a:buFont typeface="Arial"/>
-              <a:buChar char="•"/>
-            </a:pPr>
-            <a:r>
-              <a:rPr lang="en-US" sz="3268">
-                <a:solidFill>
-                  <a:srgbClr val="545454"/>
-                </a:solidFill>
-                <a:latin typeface="Garet"/>
-                <a:ea typeface="Garet"/>
-                <a:cs typeface="Garet"/>
-                <a:sym typeface="Garet"/>
-              </a:rPr>
-              <a:t>Coordinator reviews and approves / rejects</a:t>
-            </a:r>
-          </a:p>
-          <a:p>
-            <a:pPr marL="705747" lvl="1" indent="-352873" algn="l">
-              <a:lnSpc>
-                <a:spcPts val="4576"/>
-              </a:lnSpc>
-              <a:buFont typeface="Arial"/>
-              <a:buChar char="•"/>
-            </a:pPr>
-            <a:r>
-              <a:rPr lang="en-US" sz="3268">
-                <a:solidFill>
-                  <a:srgbClr val="545454"/>
-                </a:solidFill>
-                <a:latin typeface="Garet"/>
-                <a:ea typeface="Garet"/>
-                <a:cs typeface="Garet"/>
-                <a:sym typeface="Garet"/>
-              </a:rPr>
-              <a:t>Coordinator reviews and approves / rejects</a:t>
-            </a:r>
-          </a:p>
-          <a:p>
-            <a:pPr marL="705747" lvl="1" indent="-352873" algn="l">
-              <a:lnSpc>
-                <a:spcPts val="4576"/>
-              </a:lnSpc>
-              <a:buFont typeface="Arial"/>
-              <a:buChar char="•"/>
-            </a:pPr>
-            <a:r>
-              <a:rPr lang="en-US" sz="3268">
-                <a:solidFill>
-                  <a:srgbClr val="545454"/>
-                </a:solidFill>
-                <a:latin typeface="Garet"/>
-                <a:ea typeface="Garet"/>
-                <a:cs typeface="Garet"/>
-                <a:sym typeface="Garet"/>
-              </a:rPr>
-              <a:t>HR updates user and generates report</a:t>
-            </a:r>
-          </a:p>
-          <a:p>
-            <a:pPr algn="l">
-              <a:lnSpc>
-                <a:spcPts val="4576"/>
-              </a:lnSpc>
-            </a:pPr>
-            <a:endParaRPr lang="en-US" sz="3268">
-              <a:solidFill>
-                <a:srgbClr val="545454"/>
-              </a:solidFill>
-              <a:latin typeface="Garet"/>
-              <a:ea typeface="Garet"/>
-              <a:cs typeface="Garet"/>
-              <a:sym typeface="Garet"/>
-            </a:endParaRPr>
-          </a:p>
-        </p:txBody>
-      </p:sp>
-      <p:sp>
-        <p:nvSpPr>
-          <p:cNvPr id="7" name="TextBox 7"/>
-          <p:cNvSpPr txBox="1"/>
-          <p:nvPr/>
-        </p:nvSpPr>
-        <p:spPr>
-          <a:xfrm>
             <a:off x="16214256" y="9019603"/>
-            <a:ext cx="1271574" cy="803430"/>
+            <a:ext cx="1271574" cy="817275"/>
           </a:xfrm>
           <a:prstGeom prst="rect">
             <a:avLst/>
@@ -6879,7 +6776,7 @@
               </a:spcBef>
             </a:pPr>
             <a:r>
-              <a:rPr lang="en-US" sz="4743" b="1">
+              <a:rPr lang="en-US" sz="4743" b="1" dirty="0">
                 <a:solidFill>
                   <a:srgbClr val="545454"/>
                 </a:solidFill>
@@ -6893,7 +6790,132 @@
           </a:p>
         </p:txBody>
       </p:sp>
+      <p:pic>
+        <p:nvPicPr>
+          <p:cNvPr id="11" name="Picture 10">
+            <a:extLst>
+              <a:ext uri="{FF2B5EF4-FFF2-40B4-BE49-F238E27FC236}">
+                <a16:creationId xmlns:a16="http://schemas.microsoft.com/office/drawing/2014/main" id="{15C422EF-7E54-14C9-F08E-898FCF31285B}"/>
+              </a:ext>
+            </a:extLst>
+          </p:cNvPr>
+          <p:cNvPicPr>
+            <a:picLocks noChangeAspect="1"/>
+          </p:cNvPicPr>
+          <p:nvPr/>
+        </p:nvPicPr>
+        <p:blipFill>
+          <a:blip r:embed="rId6"/>
+          <a:stretch>
+            <a:fillRect/>
+          </a:stretch>
+        </p:blipFill>
+        <p:spPr>
+          <a:xfrm>
+            <a:off x="1090194" y="1240092"/>
+            <a:ext cx="5896812" cy="3931208"/>
+          </a:xfrm>
+          <a:prstGeom prst="rect">
+            <a:avLst/>
+          </a:prstGeom>
+        </p:spPr>
+      </p:pic>
+      <p:pic>
+        <p:nvPicPr>
+          <p:cNvPr id="13" name="Picture 12">
+            <a:extLst>
+              <a:ext uri="{FF2B5EF4-FFF2-40B4-BE49-F238E27FC236}">
+                <a16:creationId xmlns:a16="http://schemas.microsoft.com/office/drawing/2014/main" id="{20403D08-BEEC-FD8F-DDEE-0009B630B29B}"/>
+              </a:ext>
+            </a:extLst>
+          </p:cNvPr>
+          <p:cNvPicPr>
+            <a:picLocks noChangeAspect="1"/>
+          </p:cNvPicPr>
+          <p:nvPr/>
+        </p:nvPicPr>
+        <p:blipFill>
+          <a:blip r:embed="rId7"/>
+          <a:stretch>
+            <a:fillRect/>
+          </a:stretch>
+        </p:blipFill>
+        <p:spPr>
+          <a:xfrm>
+            <a:off x="8915400" y="1511522"/>
+            <a:ext cx="7216458" cy="3377797"/>
+          </a:xfrm>
+          <a:prstGeom prst="rect">
+            <a:avLst/>
+          </a:prstGeom>
+        </p:spPr>
+      </p:pic>
+      <p:pic>
+        <p:nvPicPr>
+          <p:cNvPr id="8" name="Picture 7">
+            <a:extLst>
+              <a:ext uri="{FF2B5EF4-FFF2-40B4-BE49-F238E27FC236}">
+                <a16:creationId xmlns:a16="http://schemas.microsoft.com/office/drawing/2014/main" id="{39820229-6E49-6EE2-56C3-FBF325425FA8}"/>
+              </a:ext>
+            </a:extLst>
+          </p:cNvPr>
+          <p:cNvPicPr>
+            <a:picLocks noChangeAspect="1"/>
+          </p:cNvPicPr>
+          <p:nvPr/>
+        </p:nvPicPr>
+        <p:blipFill>
+          <a:blip r:embed="rId8"/>
+          <a:stretch>
+            <a:fillRect/>
+          </a:stretch>
+        </p:blipFill>
+        <p:spPr>
+          <a:xfrm>
+            <a:off x="304800" y="5526612"/>
+            <a:ext cx="6887409" cy="3377797"/>
+          </a:xfrm>
+          <a:prstGeom prst="rect">
+            <a:avLst/>
+          </a:prstGeom>
+        </p:spPr>
+      </p:pic>
+      <p:pic>
+        <p:nvPicPr>
+          <p:cNvPr id="10" name="Picture 9">
+            <a:extLst>
+              <a:ext uri="{FF2B5EF4-FFF2-40B4-BE49-F238E27FC236}">
+                <a16:creationId xmlns:a16="http://schemas.microsoft.com/office/drawing/2014/main" id="{8739302F-AEA9-E5EE-6C51-E575D4FA6AAE}"/>
+              </a:ext>
+            </a:extLst>
+          </p:cNvPr>
+          <p:cNvPicPr>
+            <a:picLocks noChangeAspect="1"/>
+          </p:cNvPicPr>
+          <p:nvPr/>
+        </p:nvPicPr>
+        <p:blipFill>
+          <a:blip r:embed="rId9"/>
+          <a:stretch>
+            <a:fillRect/>
+          </a:stretch>
+        </p:blipFill>
+        <p:spPr>
+          <a:xfrm>
+            <a:off x="8854492" y="5409490"/>
+            <a:ext cx="6887408" cy="3200552"/>
+          </a:xfrm>
+          <a:prstGeom prst="rect">
+            <a:avLst/>
+          </a:prstGeom>
+        </p:spPr>
+      </p:pic>
     </p:spTree>
+    <p:extLst>
+      <p:ext uri="{BB962C8B-B14F-4D97-AF65-F5344CB8AC3E}">
+        <p14:creationId xmlns:p14="http://schemas.microsoft.com/office/powerpoint/2010/main" val="1604425038"/>
+      </p:ext>
+    </p:extLst>
   </p:cSld>
   <p:clrMapOvr>
     <a:masterClrMapping/>
@@ -6914,7 +6936,13 @@
     </p:bg>
     <p:spTree>
       <p:nvGrpSpPr>
-        <p:cNvPr id="1" name=""/>
+        <p:cNvPr id="1" name="">
+          <a:extLst>
+            <a:ext uri="{FF2B5EF4-FFF2-40B4-BE49-F238E27FC236}">
+              <a16:creationId xmlns:a16="http://schemas.microsoft.com/office/drawing/2014/main" id="{6018BC62-30E2-5CA5-E9BF-DA65FB6E013C}"/>
+            </a:ext>
+          </a:extLst>
+        </p:cNvPr>
         <p:cNvGrpSpPr/>
         <p:nvPr/>
       </p:nvGrpSpPr>
@@ -6928,7 +6956,13 @@
       </p:grpSpPr>
       <p:sp>
         <p:nvSpPr>
-          <p:cNvPr id="2" name="Freeform 2"/>
+          <p:cNvPr id="2" name="Freeform 2">
+            <a:extLst>
+              <a:ext uri="{FF2B5EF4-FFF2-40B4-BE49-F238E27FC236}">
+                <a16:creationId xmlns:a16="http://schemas.microsoft.com/office/drawing/2014/main" id="{B38D5C89-9B1F-C9EE-8DEA-9305D285E00A}"/>
+              </a:ext>
+            </a:extLst>
+          </p:cNvPr>
           <p:cNvSpPr/>
           <p:nvPr/>
         </p:nvSpPr>
@@ -6987,7 +7021,13 @@
       </p:sp>
       <p:sp>
         <p:nvSpPr>
-          <p:cNvPr id="3" name="Freeform 3"/>
+          <p:cNvPr id="3" name="Freeform 3">
+            <a:extLst>
+              <a:ext uri="{FF2B5EF4-FFF2-40B4-BE49-F238E27FC236}">
+                <a16:creationId xmlns:a16="http://schemas.microsoft.com/office/drawing/2014/main" id="{2B7A8533-F24D-A8A1-EBFA-8A18BC21C6EB}"/>
+              </a:ext>
+            </a:extLst>
+          </p:cNvPr>
           <p:cNvSpPr/>
           <p:nvPr/>
         </p:nvSpPr>
@@ -7046,7 +7086,13 @@
       </p:sp>
       <p:sp>
         <p:nvSpPr>
-          <p:cNvPr id="4" name="AutoShape 4"/>
+          <p:cNvPr id="4" name="AutoShape 4">
+            <a:extLst>
+              <a:ext uri="{FF2B5EF4-FFF2-40B4-BE49-F238E27FC236}">
+                <a16:creationId xmlns:a16="http://schemas.microsoft.com/office/drawing/2014/main" id="{0305590E-A850-66FE-89ED-440CAF2CB7AF}"/>
+              </a:ext>
+            </a:extLst>
+          </p:cNvPr>
           <p:cNvSpPr/>
           <p:nvPr/>
         </p:nvSpPr>
@@ -7077,120 +7123,20 @@
       </p:sp>
       <p:sp>
         <p:nvSpPr>
-          <p:cNvPr id="5" name="Freeform 5"/>
-          <p:cNvSpPr/>
-          <p:nvPr/>
-        </p:nvSpPr>
-        <p:spPr>
-          <a:xfrm>
-            <a:off x="4541415" y="5447355"/>
-            <a:ext cx="4014676" cy="1824853"/>
-          </a:xfrm>
-          <a:custGeom>
-            <a:avLst/>
-            <a:gdLst/>
-            <a:ahLst/>
-            <a:cxnLst/>
-            <a:rect l="l" t="t" r="r" b="b"/>
-            <a:pathLst>
-              <a:path w="4014676" h="1824853">
-                <a:moveTo>
-                  <a:pt x="0" y="0"/>
-                </a:moveTo>
-                <a:lnTo>
-                  <a:pt x="4014677" y="0"/>
-                </a:lnTo>
-                <a:lnTo>
-                  <a:pt x="4014677" y="1824853"/>
-                </a:lnTo>
-                <a:lnTo>
-                  <a:pt x="0" y="1824853"/>
-                </a:lnTo>
-                <a:lnTo>
-                  <a:pt x="0" y="0"/>
-                </a:lnTo>
-                <a:close/>
-              </a:path>
-            </a:pathLst>
-          </a:custGeom>
-          <a:blipFill>
-            <a:blip r:embed="rId6"/>
-            <a:stretch>
-              <a:fillRect/>
-            </a:stretch>
-          </a:blipFill>
-        </p:spPr>
-        <p:txBody>
-          <a:bodyPr/>
-          <a:lstStyle/>
-          <a:p>
-            <a:endParaRPr lang="en-GB"/>
-          </a:p>
-        </p:txBody>
-      </p:sp>
-      <p:sp>
-        <p:nvSpPr>
-          <p:cNvPr id="6" name="Freeform 6"/>
-          <p:cNvSpPr/>
-          <p:nvPr/>
-        </p:nvSpPr>
-        <p:spPr>
-          <a:xfrm>
-            <a:off x="9469802" y="4242912"/>
-            <a:ext cx="5078672" cy="4635120"/>
-          </a:xfrm>
-          <a:custGeom>
-            <a:avLst/>
-            <a:gdLst/>
-            <a:ahLst/>
-            <a:cxnLst/>
-            <a:rect l="l" t="t" r="r" b="b"/>
-            <a:pathLst>
-              <a:path w="5078672" h="4635120">
-                <a:moveTo>
-                  <a:pt x="0" y="0"/>
-                </a:moveTo>
-                <a:lnTo>
-                  <a:pt x="5078672" y="0"/>
-                </a:lnTo>
-                <a:lnTo>
-                  <a:pt x="5078672" y="4635120"/>
-                </a:lnTo>
-                <a:lnTo>
-                  <a:pt x="0" y="4635120"/>
-                </a:lnTo>
-                <a:lnTo>
-                  <a:pt x="0" y="0"/>
-                </a:lnTo>
-                <a:close/>
-              </a:path>
-            </a:pathLst>
-          </a:custGeom>
-          <a:blipFill>
-            <a:blip r:embed="rId7"/>
-            <a:stretch>
-              <a:fillRect/>
-            </a:stretch>
-          </a:blipFill>
-        </p:spPr>
-        <p:txBody>
-          <a:bodyPr/>
-          <a:lstStyle/>
-          <a:p>
-            <a:endParaRPr lang="en-GB"/>
-          </a:p>
-        </p:txBody>
-      </p:sp>
-      <p:sp>
-        <p:nvSpPr>
-          <p:cNvPr id="7" name="TextBox 7"/>
+          <p:cNvPr id="5" name="TextBox 5">
+            <a:extLst>
+              <a:ext uri="{FF2B5EF4-FFF2-40B4-BE49-F238E27FC236}">
+                <a16:creationId xmlns:a16="http://schemas.microsoft.com/office/drawing/2014/main" id="{445D5EC8-945E-C868-2A41-EC52DF717D80}"/>
+              </a:ext>
+            </a:extLst>
+          </p:cNvPr>
           <p:cNvSpPr txBox="1"/>
           <p:nvPr/>
         </p:nvSpPr>
         <p:spPr>
           <a:xfrm>
-            <a:off x="2974910" y="120570"/>
-            <a:ext cx="12624901" cy="1268973"/>
+            <a:off x="3876712" y="-152400"/>
+            <a:ext cx="12038072" cy="1392492"/>
           </a:xfrm>
           <a:prstGeom prst="rect">
             <a:avLst/>
@@ -7204,11 +7150,11 @@
           <a:p>
             <a:pPr algn="ctr">
               <a:lnSpc>
-                <a:spcPts val="10396"/>
+                <a:spcPts val="11448"/>
               </a:lnSpc>
             </a:pPr>
             <a:r>
-              <a:rPr lang="en-US" sz="7425" b="1">
+              <a:rPr lang="en-US" sz="8177" b="1">
                 <a:solidFill>
                   <a:srgbClr val="3F3D3E"/>
                 </a:solidFill>
@@ -7217,130 +7163,27 @@
                 <a:cs typeface="Alexandria Bold"/>
                 <a:sym typeface="Alexandria Bold"/>
               </a:rPr>
-              <a:t>Feedback changes</a:t>
-            </a:r>
-          </a:p>
-        </p:txBody>
-      </p:sp>
-      <p:sp>
-        <p:nvSpPr>
-          <p:cNvPr id="8" name="TextBox 8"/>
+              <a:t>Database Structure</a:t>
+            </a:r>
+          </a:p>
+        </p:txBody>
+      </p:sp>
+      <p:sp>
+        <p:nvSpPr>
+          <p:cNvPr id="6" name="TextBox 6">
+            <a:extLst>
+              <a:ext uri="{FF2B5EF4-FFF2-40B4-BE49-F238E27FC236}">
+                <a16:creationId xmlns:a16="http://schemas.microsoft.com/office/drawing/2014/main" id="{1E3471AA-D42E-FA55-BB42-624455E6B629}"/>
+              </a:ext>
+            </a:extLst>
+          </p:cNvPr>
           <p:cNvSpPr txBox="1"/>
           <p:nvPr/>
         </p:nvSpPr>
         <p:spPr>
           <a:xfrm>
-            <a:off x="3349093" y="1569282"/>
-            <a:ext cx="11876536" cy="2888771"/>
-          </a:xfrm>
-          <a:prstGeom prst="rect">
-            <a:avLst/>
-          </a:prstGeom>
-        </p:spPr>
-        <p:txBody>
-          <a:bodyPr lIns="0" tIns="0" rIns="0" bIns="0" rtlCol="0" anchor="t">
-            <a:spAutoFit/>
-          </a:bodyPr>
-          <a:lstStyle/>
-          <a:p>
-            <a:pPr algn="l">
-              <a:lnSpc>
-                <a:spcPts val="4576"/>
-              </a:lnSpc>
-            </a:pPr>
-            <a:endParaRPr/>
-          </a:p>
-          <a:p>
-            <a:pPr marL="705747" lvl="1" indent="-352873" algn="l">
-              <a:lnSpc>
-                <a:spcPts val="4576"/>
-              </a:lnSpc>
-              <a:buFont typeface="Arial"/>
-              <a:buChar char="•"/>
-            </a:pPr>
-            <a:r>
-              <a:rPr lang="en-US" sz="3268">
-                <a:solidFill>
-                  <a:srgbClr val="545454"/>
-                </a:solidFill>
-                <a:latin typeface="Garet"/>
-                <a:ea typeface="Garet"/>
-                <a:cs typeface="Garet"/>
-                <a:sym typeface="Garet"/>
-              </a:rPr>
-              <a:t>File name does not show, only “Download”</a:t>
-            </a:r>
-          </a:p>
-          <a:p>
-            <a:pPr marL="705747" lvl="1" indent="-352873" algn="l">
-              <a:lnSpc>
-                <a:spcPts val="4576"/>
-              </a:lnSpc>
-              <a:buFont typeface="Arial"/>
-              <a:buChar char="•"/>
-            </a:pPr>
-            <a:r>
-              <a:rPr lang="en-US" sz="3268">
-                <a:solidFill>
-                  <a:srgbClr val="545454"/>
-                </a:solidFill>
-                <a:latin typeface="Garet"/>
-                <a:ea typeface="Garet"/>
-                <a:cs typeface="Garet"/>
-                <a:sym typeface="Garet"/>
-              </a:rPr>
-              <a:t>Lecturer cannot change their hourly rate</a:t>
-            </a:r>
-          </a:p>
-          <a:p>
-            <a:pPr marL="705747" lvl="1" indent="-352873" algn="l">
-              <a:lnSpc>
-                <a:spcPts val="4576"/>
-              </a:lnSpc>
-              <a:buFont typeface="Arial"/>
-              <a:buChar char="•"/>
-            </a:pPr>
-            <a:r>
-              <a:rPr lang="en-US" sz="3268">
-                <a:solidFill>
-                  <a:srgbClr val="545454"/>
-                </a:solidFill>
-                <a:latin typeface="Garet"/>
-                <a:ea typeface="Garet"/>
-                <a:cs typeface="Garet"/>
-                <a:sym typeface="Garet"/>
-              </a:rPr>
-              <a:t>Option to upload document in “Submit Claim” page</a:t>
-            </a:r>
-          </a:p>
-          <a:p>
-            <a:pPr algn="l">
-              <a:lnSpc>
-                <a:spcPts val="4576"/>
-              </a:lnSpc>
-            </a:pPr>
-            <a:endParaRPr lang="en-US" sz="3268">
-              <a:solidFill>
-                <a:srgbClr val="545454"/>
-              </a:solidFill>
-              <a:latin typeface="Garet"/>
-              <a:ea typeface="Garet"/>
-              <a:cs typeface="Garet"/>
-              <a:sym typeface="Garet"/>
-            </a:endParaRPr>
-          </a:p>
-        </p:txBody>
-      </p:sp>
-      <p:sp>
-        <p:nvSpPr>
-          <p:cNvPr id="9" name="TextBox 9"/>
-          <p:cNvSpPr txBox="1"/>
-          <p:nvPr/>
-        </p:nvSpPr>
-        <p:spPr>
-          <a:xfrm>
             <a:off x="16214256" y="9019603"/>
-            <a:ext cx="1271574" cy="803430"/>
+            <a:ext cx="1271574" cy="817275"/>
           </a:xfrm>
           <a:prstGeom prst="rect">
             <a:avLst/>
@@ -7361,7 +7204,7 @@
               </a:spcBef>
             </a:pPr>
             <a:r>
-              <a:rPr lang="en-US" sz="4743" b="1">
+              <a:rPr lang="en-US" sz="4743" b="1" dirty="0">
                 <a:solidFill>
                   <a:srgbClr val="545454"/>
                 </a:solidFill>
@@ -7375,7 +7218,72 @@
           </a:p>
         </p:txBody>
       </p:sp>
+      <p:pic>
+        <p:nvPicPr>
+          <p:cNvPr id="15" name="Picture 14">
+            <a:extLst>
+              <a:ext uri="{FF2B5EF4-FFF2-40B4-BE49-F238E27FC236}">
+                <a16:creationId xmlns:a16="http://schemas.microsoft.com/office/drawing/2014/main" id="{17EF118F-879F-A348-FA43-CD259DD8852E}"/>
+              </a:ext>
+            </a:extLst>
+          </p:cNvPr>
+          <p:cNvPicPr>
+            <a:picLocks noChangeAspect="1"/>
+          </p:cNvPicPr>
+          <p:nvPr/>
+        </p:nvPicPr>
+        <p:blipFill>
+          <a:blip r:embed="rId6"/>
+          <a:stretch>
+            <a:fillRect/>
+          </a:stretch>
+        </p:blipFill>
+        <p:spPr>
+          <a:xfrm>
+            <a:off x="4540243" y="1553753"/>
+            <a:ext cx="8411302" cy="3490614"/>
+          </a:xfrm>
+          <a:prstGeom prst="rect">
+            <a:avLst/>
+          </a:prstGeom>
+        </p:spPr>
+      </p:pic>
+      <p:pic>
+        <p:nvPicPr>
+          <p:cNvPr id="17" name="Picture 16">
+            <a:extLst>
+              <a:ext uri="{FF2B5EF4-FFF2-40B4-BE49-F238E27FC236}">
+                <a16:creationId xmlns:a16="http://schemas.microsoft.com/office/drawing/2014/main" id="{DC4968D9-B933-785F-D683-612D2898B16C}"/>
+              </a:ext>
+            </a:extLst>
+          </p:cNvPr>
+          <p:cNvPicPr>
+            <a:picLocks noChangeAspect="1"/>
+          </p:cNvPicPr>
+          <p:nvPr/>
+        </p:nvPicPr>
+        <p:blipFill>
+          <a:blip r:embed="rId7"/>
+          <a:stretch>
+            <a:fillRect/>
+          </a:stretch>
+        </p:blipFill>
+        <p:spPr>
+          <a:xfrm>
+            <a:off x="4235719" y="5233993"/>
+            <a:ext cx="9282363" cy="3686508"/>
+          </a:xfrm>
+          <a:prstGeom prst="rect">
+            <a:avLst/>
+          </a:prstGeom>
+        </p:spPr>
+      </p:pic>
     </p:spTree>
+    <p:extLst>
+      <p:ext uri="{BB962C8B-B14F-4D97-AF65-F5344CB8AC3E}">
+        <p14:creationId xmlns:p14="http://schemas.microsoft.com/office/powerpoint/2010/main" val="464516796"/>
+      </p:ext>
+    </p:extLst>
   </p:cSld>
   <p:clrMapOvr>
     <a:masterClrMapping/>
@@ -7469,173 +7377,7 @@
       </p:sp>
       <p:sp>
         <p:nvSpPr>
-          <p:cNvPr id="3" name="TextBox 3"/>
-          <p:cNvSpPr txBox="1"/>
-          <p:nvPr/>
-        </p:nvSpPr>
-        <p:spPr>
-          <a:xfrm>
-            <a:off x="4541415" y="1000865"/>
-            <a:ext cx="9205169" cy="1392492"/>
-          </a:xfrm>
-          <a:prstGeom prst="rect">
-            <a:avLst/>
-          </a:prstGeom>
-        </p:spPr>
-        <p:txBody>
-          <a:bodyPr lIns="0" tIns="0" rIns="0" bIns="0" rtlCol="0" anchor="t">
-            <a:spAutoFit/>
-          </a:bodyPr>
-          <a:lstStyle/>
-          <a:p>
-            <a:pPr algn="ctr">
-              <a:lnSpc>
-                <a:spcPts val="11448"/>
-              </a:lnSpc>
-            </a:pPr>
-            <a:r>
-              <a:rPr lang="en-US" sz="8177" b="1">
-                <a:solidFill>
-                  <a:srgbClr val="3F3D3E"/>
-                </a:solidFill>
-                <a:latin typeface="Alexandria Bold"/>
-                <a:ea typeface="Alexandria Bold"/>
-                <a:cs typeface="Alexandria Bold"/>
-                <a:sym typeface="Alexandria Bold"/>
-              </a:rPr>
-              <a:t>CONCLUSION</a:t>
-            </a:r>
-          </a:p>
-        </p:txBody>
-      </p:sp>
-      <p:sp>
-        <p:nvSpPr>
-          <p:cNvPr id="4" name="TextBox 4"/>
-          <p:cNvSpPr txBox="1"/>
-          <p:nvPr/>
-        </p:nvSpPr>
-        <p:spPr>
-          <a:xfrm>
-            <a:off x="3728730" y="3867640"/>
-            <a:ext cx="11400286" cy="4631846"/>
-          </a:xfrm>
-          <a:prstGeom prst="rect">
-            <a:avLst/>
-          </a:prstGeom>
-        </p:spPr>
-        <p:txBody>
-          <a:bodyPr lIns="0" tIns="0" rIns="0" bIns="0" rtlCol="0" anchor="t">
-            <a:spAutoFit/>
-          </a:bodyPr>
-          <a:lstStyle/>
-          <a:p>
-            <a:pPr marL="705747" lvl="1" indent="-352873" algn="l">
-              <a:lnSpc>
-                <a:spcPts val="4576"/>
-              </a:lnSpc>
-              <a:buFont typeface="Arial"/>
-              <a:buChar char="•"/>
-            </a:pPr>
-            <a:r>
-              <a:rPr lang="en-US" sz="3268">
-                <a:solidFill>
-                  <a:srgbClr val="545454"/>
-                </a:solidFill>
-                <a:latin typeface="Garet"/>
-                <a:ea typeface="Garet"/>
-                <a:cs typeface="Garet"/>
-                <a:sym typeface="Garet"/>
-              </a:rPr>
-              <a:t>CMCS improves accuracy and reduces manual admin</a:t>
-            </a:r>
-          </a:p>
-          <a:p>
-            <a:pPr marL="705747" lvl="1" indent="-352873" algn="l">
-              <a:lnSpc>
-                <a:spcPts val="4576"/>
-              </a:lnSpc>
-              <a:buFont typeface="Arial"/>
-              <a:buChar char="•"/>
-            </a:pPr>
-            <a:r>
-              <a:rPr lang="en-US" sz="3268">
-                <a:solidFill>
-                  <a:srgbClr val="545454"/>
-                </a:solidFill>
-                <a:latin typeface="Garet"/>
-                <a:ea typeface="Garet"/>
-                <a:cs typeface="Garet"/>
-                <a:sym typeface="Garet"/>
-              </a:rPr>
-              <a:t>Provides clear workflow between roles</a:t>
-            </a:r>
-          </a:p>
-          <a:p>
-            <a:pPr marL="705747" lvl="1" indent="-352873" algn="l">
-              <a:lnSpc>
-                <a:spcPts val="4576"/>
-              </a:lnSpc>
-              <a:buFont typeface="Arial"/>
-              <a:buChar char="•"/>
-            </a:pPr>
-            <a:r>
-              <a:rPr lang="en-US" sz="3268">
-                <a:solidFill>
-                  <a:srgbClr val="545454"/>
-                </a:solidFill>
-                <a:latin typeface="Garet"/>
-                <a:ea typeface="Garet"/>
-                <a:cs typeface="Garet"/>
-                <a:sym typeface="Garet"/>
-              </a:rPr>
-              <a:t>Secure, user-friendly and database-driven system</a:t>
-            </a:r>
-          </a:p>
-          <a:p>
-            <a:pPr marL="705747" lvl="1" indent="-352873" algn="l">
-              <a:lnSpc>
-                <a:spcPts val="4576"/>
-              </a:lnSpc>
-              <a:buFont typeface="Arial"/>
-              <a:buChar char="•"/>
-            </a:pPr>
-            <a:r>
-              <a:rPr lang="en-US" sz="3268">
-                <a:solidFill>
-                  <a:srgbClr val="545454"/>
-                </a:solidFill>
-                <a:latin typeface="Garet"/>
-                <a:ea typeface="Garet"/>
-                <a:cs typeface="Garet"/>
-                <a:sym typeface="Garet"/>
-              </a:rPr>
-              <a:t>Meets all automation, validation, and reporting requirements</a:t>
-            </a:r>
-          </a:p>
-          <a:p>
-            <a:pPr algn="ctr">
-              <a:lnSpc>
-                <a:spcPts val="4576"/>
-              </a:lnSpc>
-              <a:spcBef>
-                <a:spcPct val="0"/>
-              </a:spcBef>
-            </a:pPr>
-            <a:endParaRPr lang="en-US" sz="3268">
-              <a:solidFill>
-                <a:srgbClr val="545454"/>
-              </a:solidFill>
-              <a:latin typeface="Garet"/>
-              <a:ea typeface="Garet"/>
-              <a:cs typeface="Garet"/>
-              <a:sym typeface="Garet"/>
-            </a:endParaRPr>
-          </a:p>
-        </p:txBody>
-      </p:sp>
-      <p:sp>
-        <p:nvSpPr>
-          <p:cNvPr id="5" name="Freeform 5"/>
+          <p:cNvPr id="3" name="Freeform 3"/>
           <p:cNvSpPr/>
           <p:nvPr/>
         </p:nvSpPr>
@@ -7694,7 +7436,7 @@
       </p:sp>
       <p:sp>
         <p:nvSpPr>
-          <p:cNvPr id="6" name="AutoShape 6"/>
+          <p:cNvPr id="4" name="AutoShape 4"/>
           <p:cNvSpPr/>
           <p:nvPr/>
         </p:nvSpPr>
@@ -7725,6 +7467,188 @@
       </p:sp>
       <p:sp>
         <p:nvSpPr>
+          <p:cNvPr id="5" name="TextBox 5"/>
+          <p:cNvSpPr txBox="1"/>
+          <p:nvPr/>
+        </p:nvSpPr>
+        <p:spPr>
+          <a:xfrm>
+            <a:off x="2831550" y="550652"/>
+            <a:ext cx="12624901" cy="1268973"/>
+          </a:xfrm>
+          <a:prstGeom prst="rect">
+            <a:avLst/>
+          </a:prstGeom>
+        </p:spPr>
+        <p:txBody>
+          <a:bodyPr lIns="0" tIns="0" rIns="0" bIns="0" rtlCol="0" anchor="t">
+            <a:spAutoFit/>
+          </a:bodyPr>
+          <a:lstStyle/>
+          <a:p>
+            <a:pPr algn="ctr">
+              <a:lnSpc>
+                <a:spcPts val="10396"/>
+              </a:lnSpc>
+            </a:pPr>
+            <a:r>
+              <a:rPr lang="en-US" sz="7425" b="1">
+                <a:solidFill>
+                  <a:srgbClr val="3F3D3E"/>
+                </a:solidFill>
+                <a:latin typeface="Alexandria Bold"/>
+                <a:ea typeface="Alexandria Bold"/>
+                <a:cs typeface="Alexandria Bold"/>
+                <a:sym typeface="Alexandria Bold"/>
+              </a:rPr>
+              <a:t>Demonstration Summary</a:t>
+            </a:r>
+          </a:p>
+        </p:txBody>
+      </p:sp>
+      <p:sp>
+        <p:nvSpPr>
+          <p:cNvPr id="6" name="TextBox 6"/>
+          <p:cNvSpPr txBox="1"/>
+          <p:nvPr/>
+        </p:nvSpPr>
+        <p:spPr>
+          <a:xfrm>
+            <a:off x="3205732" y="3024506"/>
+            <a:ext cx="11876536" cy="3469796"/>
+          </a:xfrm>
+          <a:prstGeom prst="rect">
+            <a:avLst/>
+          </a:prstGeom>
+        </p:spPr>
+        <p:txBody>
+          <a:bodyPr lIns="0" tIns="0" rIns="0" bIns="0" rtlCol="0" anchor="t">
+            <a:spAutoFit/>
+          </a:bodyPr>
+          <a:lstStyle/>
+          <a:p>
+            <a:pPr algn="l">
+              <a:lnSpc>
+                <a:spcPts val="4576"/>
+              </a:lnSpc>
+            </a:pPr>
+            <a:r>
+              <a:rPr lang="en-US" sz="3268">
+                <a:solidFill>
+                  <a:srgbClr val="545454"/>
+                </a:solidFill>
+                <a:latin typeface="Garet"/>
+                <a:ea typeface="Garet"/>
+                <a:cs typeface="Garet"/>
+                <a:sym typeface="Garet"/>
+              </a:rPr>
+              <a:t>Summaries of key workflows:</a:t>
+            </a:r>
+          </a:p>
+          <a:p>
+            <a:pPr marL="705747" lvl="1" indent="-352873" algn="l">
+              <a:lnSpc>
+                <a:spcPts val="4576"/>
+              </a:lnSpc>
+              <a:buFont typeface="Arial"/>
+              <a:buChar char="•"/>
+            </a:pPr>
+            <a:r>
+              <a:rPr lang="en-US" sz="3268">
+                <a:solidFill>
+                  <a:srgbClr val="545454"/>
+                </a:solidFill>
+                <a:latin typeface="Garet"/>
+                <a:ea typeface="Garet"/>
+                <a:cs typeface="Garet"/>
+                <a:sym typeface="Garet"/>
+              </a:rPr>
+              <a:t>Lecturer submits claim</a:t>
+            </a:r>
+          </a:p>
+          <a:p>
+            <a:pPr marL="705747" lvl="1" indent="-352873" algn="l">
+              <a:lnSpc>
+                <a:spcPts val="4576"/>
+              </a:lnSpc>
+              <a:buFont typeface="Arial"/>
+              <a:buChar char="•"/>
+            </a:pPr>
+            <a:r>
+              <a:rPr lang="en-US" sz="3268">
+                <a:solidFill>
+                  <a:srgbClr val="545454"/>
+                </a:solidFill>
+                <a:latin typeface="Garet"/>
+                <a:ea typeface="Garet"/>
+                <a:cs typeface="Garet"/>
+                <a:sym typeface="Garet"/>
+              </a:rPr>
+              <a:t>Coordinator reviews and approves / rejects</a:t>
+            </a:r>
+          </a:p>
+          <a:p>
+            <a:pPr marL="705747" lvl="1" indent="-352873" algn="l">
+              <a:lnSpc>
+                <a:spcPts val="4576"/>
+              </a:lnSpc>
+              <a:buFont typeface="Arial"/>
+              <a:buChar char="•"/>
+            </a:pPr>
+            <a:r>
+              <a:rPr lang="en-US" sz="3268">
+                <a:solidFill>
+                  <a:srgbClr val="545454"/>
+                </a:solidFill>
+                <a:latin typeface="Garet"/>
+                <a:ea typeface="Garet"/>
+                <a:cs typeface="Garet"/>
+                <a:sym typeface="Garet"/>
+              </a:rPr>
+              <a:t>Coordinator reviews and approves / rejects</a:t>
+            </a:r>
+          </a:p>
+          <a:p>
+            <a:pPr marL="705747" lvl="1" indent="-352873" algn="l">
+              <a:lnSpc>
+                <a:spcPts val="4576"/>
+              </a:lnSpc>
+              <a:buFont typeface="Arial"/>
+              <a:buChar char="•"/>
+            </a:pPr>
+            <a:r>
+              <a:rPr lang="en-US" sz="3268">
+                <a:solidFill>
+                  <a:srgbClr val="545454"/>
+                </a:solidFill>
+                <a:latin typeface="Garet"/>
+                <a:ea typeface="Garet"/>
+                <a:cs typeface="Garet"/>
+                <a:sym typeface="Garet"/>
+              </a:rPr>
+              <a:t>HR updates user and generates report</a:t>
+            </a:r>
+          </a:p>
+          <a:p>
+            <a:pPr algn="l">
+              <a:lnSpc>
+                <a:spcPts val="4576"/>
+              </a:lnSpc>
+            </a:pPr>
+            <a:endParaRPr lang="en-US" sz="3268">
+              <a:solidFill>
+                <a:srgbClr val="545454"/>
+              </a:solidFill>
+              <a:latin typeface="Garet"/>
+              <a:ea typeface="Garet"/>
+              <a:cs typeface="Garet"/>
+              <a:sym typeface="Garet"/>
+            </a:endParaRPr>
+          </a:p>
+        </p:txBody>
+      </p:sp>
+      <p:sp>
+        <p:nvSpPr>
           <p:cNvPr id="7" name="TextBox 7"/>
           <p:cNvSpPr txBox="1"/>
           <p:nvPr/>
@@ -7732,7 +7656,7 @@
         <p:spPr>
           <a:xfrm>
             <a:off x="16214256" y="9019603"/>
-            <a:ext cx="1271574" cy="803430"/>
+            <a:ext cx="1271574" cy="817275"/>
           </a:xfrm>
           <a:prstGeom prst="rect">
             <a:avLst/>
@@ -7753,7 +7677,7 @@
               </a:spcBef>
             </a:pPr>
             <a:r>
-              <a:rPr lang="en-US" sz="4743" b="1">
+              <a:rPr lang="en-US" sz="4743" b="1" dirty="0">
                 <a:solidFill>
                   <a:srgbClr val="545454"/>
                 </a:solidFill>
@@ -8225,48 +8149,7 @@
       </p:sp>
       <p:sp>
         <p:nvSpPr>
-          <p:cNvPr id="3" name="TextBox 3"/>
-          <p:cNvSpPr txBox="1"/>
-          <p:nvPr/>
-        </p:nvSpPr>
-        <p:spPr>
-          <a:xfrm>
-            <a:off x="2668325" y="4041844"/>
-            <a:ext cx="12951349" cy="1974712"/>
-          </a:xfrm>
-          <a:prstGeom prst="rect">
-            <a:avLst/>
-          </a:prstGeom>
-        </p:spPr>
-        <p:txBody>
-          <a:bodyPr lIns="0" tIns="0" rIns="0" bIns="0" rtlCol="0" anchor="t">
-            <a:spAutoFit/>
-          </a:bodyPr>
-          <a:lstStyle/>
-          <a:p>
-            <a:pPr algn="ctr">
-              <a:lnSpc>
-                <a:spcPts val="16107"/>
-              </a:lnSpc>
-            </a:pPr>
-            <a:r>
-              <a:rPr lang="en-US" sz="11505" b="1">
-                <a:solidFill>
-                  <a:srgbClr val="3F3D3E"/>
-                </a:solidFill>
-                <a:latin typeface="Alexandria Bold"/>
-                <a:ea typeface="Alexandria Bold"/>
-                <a:cs typeface="Alexandria Bold"/>
-                <a:sym typeface="Alexandria Bold"/>
-              </a:rPr>
-              <a:t>THANK YOU</a:t>
-            </a:r>
-          </a:p>
-        </p:txBody>
-      </p:sp>
-      <p:sp>
-        <p:nvSpPr>
-          <p:cNvPr id="4" name="Freeform 4"/>
+          <p:cNvPr id="3" name="Freeform 3"/>
           <p:cNvSpPr/>
           <p:nvPr/>
         </p:nvSpPr>
@@ -8325,7 +8208,7 @@
       </p:sp>
       <p:sp>
         <p:nvSpPr>
-          <p:cNvPr id="5" name="AutoShape 5"/>
+          <p:cNvPr id="4" name="AutoShape 4"/>
           <p:cNvSpPr/>
           <p:nvPr/>
         </p:nvSpPr>
@@ -8356,6 +8239,921 @@
       </p:sp>
       <p:sp>
         <p:nvSpPr>
+          <p:cNvPr id="5" name="Freeform 5"/>
+          <p:cNvSpPr/>
+          <p:nvPr/>
+        </p:nvSpPr>
+        <p:spPr>
+          <a:xfrm>
+            <a:off x="4541415" y="5447355"/>
+            <a:ext cx="4014676" cy="1824853"/>
+          </a:xfrm>
+          <a:custGeom>
+            <a:avLst/>
+            <a:gdLst/>
+            <a:ahLst/>
+            <a:cxnLst/>
+            <a:rect l="l" t="t" r="r" b="b"/>
+            <a:pathLst>
+              <a:path w="4014676" h="1824853">
+                <a:moveTo>
+                  <a:pt x="0" y="0"/>
+                </a:moveTo>
+                <a:lnTo>
+                  <a:pt x="4014677" y="0"/>
+                </a:lnTo>
+                <a:lnTo>
+                  <a:pt x="4014677" y="1824853"/>
+                </a:lnTo>
+                <a:lnTo>
+                  <a:pt x="0" y="1824853"/>
+                </a:lnTo>
+                <a:lnTo>
+                  <a:pt x="0" y="0"/>
+                </a:lnTo>
+                <a:close/>
+              </a:path>
+            </a:pathLst>
+          </a:custGeom>
+          <a:blipFill>
+            <a:blip r:embed="rId6"/>
+            <a:stretch>
+              <a:fillRect/>
+            </a:stretch>
+          </a:blipFill>
+        </p:spPr>
+        <p:txBody>
+          <a:bodyPr/>
+          <a:lstStyle/>
+          <a:p>
+            <a:endParaRPr lang="en-GB"/>
+          </a:p>
+        </p:txBody>
+      </p:sp>
+      <p:sp>
+        <p:nvSpPr>
+          <p:cNvPr id="6" name="Freeform 6"/>
+          <p:cNvSpPr/>
+          <p:nvPr/>
+        </p:nvSpPr>
+        <p:spPr>
+          <a:xfrm>
+            <a:off x="9469802" y="4242912"/>
+            <a:ext cx="5078672" cy="4635120"/>
+          </a:xfrm>
+          <a:custGeom>
+            <a:avLst/>
+            <a:gdLst/>
+            <a:ahLst/>
+            <a:cxnLst/>
+            <a:rect l="l" t="t" r="r" b="b"/>
+            <a:pathLst>
+              <a:path w="5078672" h="4635120">
+                <a:moveTo>
+                  <a:pt x="0" y="0"/>
+                </a:moveTo>
+                <a:lnTo>
+                  <a:pt x="5078672" y="0"/>
+                </a:lnTo>
+                <a:lnTo>
+                  <a:pt x="5078672" y="4635120"/>
+                </a:lnTo>
+                <a:lnTo>
+                  <a:pt x="0" y="4635120"/>
+                </a:lnTo>
+                <a:lnTo>
+                  <a:pt x="0" y="0"/>
+                </a:lnTo>
+                <a:close/>
+              </a:path>
+            </a:pathLst>
+          </a:custGeom>
+          <a:blipFill>
+            <a:blip r:embed="rId7"/>
+            <a:stretch>
+              <a:fillRect/>
+            </a:stretch>
+          </a:blipFill>
+        </p:spPr>
+        <p:txBody>
+          <a:bodyPr/>
+          <a:lstStyle/>
+          <a:p>
+            <a:endParaRPr lang="en-GB"/>
+          </a:p>
+        </p:txBody>
+      </p:sp>
+      <p:sp>
+        <p:nvSpPr>
+          <p:cNvPr id="7" name="TextBox 7"/>
+          <p:cNvSpPr txBox="1"/>
+          <p:nvPr/>
+        </p:nvSpPr>
+        <p:spPr>
+          <a:xfrm>
+            <a:off x="2974910" y="120570"/>
+            <a:ext cx="12624901" cy="1268973"/>
+          </a:xfrm>
+          <a:prstGeom prst="rect">
+            <a:avLst/>
+          </a:prstGeom>
+        </p:spPr>
+        <p:txBody>
+          <a:bodyPr lIns="0" tIns="0" rIns="0" bIns="0" rtlCol="0" anchor="t">
+            <a:spAutoFit/>
+          </a:bodyPr>
+          <a:lstStyle/>
+          <a:p>
+            <a:pPr algn="ctr">
+              <a:lnSpc>
+                <a:spcPts val="10396"/>
+              </a:lnSpc>
+            </a:pPr>
+            <a:r>
+              <a:rPr lang="en-US" sz="7425" b="1">
+                <a:solidFill>
+                  <a:srgbClr val="3F3D3E"/>
+                </a:solidFill>
+                <a:latin typeface="Alexandria Bold"/>
+                <a:ea typeface="Alexandria Bold"/>
+                <a:cs typeface="Alexandria Bold"/>
+                <a:sym typeface="Alexandria Bold"/>
+              </a:rPr>
+              <a:t>Feedback changes</a:t>
+            </a:r>
+          </a:p>
+        </p:txBody>
+      </p:sp>
+      <p:sp>
+        <p:nvSpPr>
+          <p:cNvPr id="8" name="TextBox 8"/>
+          <p:cNvSpPr txBox="1"/>
+          <p:nvPr/>
+        </p:nvSpPr>
+        <p:spPr>
+          <a:xfrm>
+            <a:off x="3349093" y="1569282"/>
+            <a:ext cx="11876536" cy="2888771"/>
+          </a:xfrm>
+          <a:prstGeom prst="rect">
+            <a:avLst/>
+          </a:prstGeom>
+        </p:spPr>
+        <p:txBody>
+          <a:bodyPr lIns="0" tIns="0" rIns="0" bIns="0" rtlCol="0" anchor="t">
+            <a:spAutoFit/>
+          </a:bodyPr>
+          <a:lstStyle/>
+          <a:p>
+            <a:pPr algn="l">
+              <a:lnSpc>
+                <a:spcPts val="4576"/>
+              </a:lnSpc>
+            </a:pPr>
+            <a:endParaRPr/>
+          </a:p>
+          <a:p>
+            <a:pPr marL="705747" lvl="1" indent="-352873" algn="l">
+              <a:lnSpc>
+                <a:spcPts val="4576"/>
+              </a:lnSpc>
+              <a:buFont typeface="Arial"/>
+              <a:buChar char="•"/>
+            </a:pPr>
+            <a:r>
+              <a:rPr lang="en-US" sz="3268">
+                <a:solidFill>
+                  <a:srgbClr val="545454"/>
+                </a:solidFill>
+                <a:latin typeface="Garet"/>
+                <a:ea typeface="Garet"/>
+                <a:cs typeface="Garet"/>
+                <a:sym typeface="Garet"/>
+              </a:rPr>
+              <a:t>File name does not show, only “Download”</a:t>
+            </a:r>
+          </a:p>
+          <a:p>
+            <a:pPr marL="705747" lvl="1" indent="-352873" algn="l">
+              <a:lnSpc>
+                <a:spcPts val="4576"/>
+              </a:lnSpc>
+              <a:buFont typeface="Arial"/>
+              <a:buChar char="•"/>
+            </a:pPr>
+            <a:r>
+              <a:rPr lang="en-US" sz="3268">
+                <a:solidFill>
+                  <a:srgbClr val="545454"/>
+                </a:solidFill>
+                <a:latin typeface="Garet"/>
+                <a:ea typeface="Garet"/>
+                <a:cs typeface="Garet"/>
+                <a:sym typeface="Garet"/>
+              </a:rPr>
+              <a:t>Lecturer cannot change their hourly rate</a:t>
+            </a:r>
+          </a:p>
+          <a:p>
+            <a:pPr marL="705747" lvl="1" indent="-352873" algn="l">
+              <a:lnSpc>
+                <a:spcPts val="4576"/>
+              </a:lnSpc>
+              <a:buFont typeface="Arial"/>
+              <a:buChar char="•"/>
+            </a:pPr>
+            <a:r>
+              <a:rPr lang="en-US" sz="3268">
+                <a:solidFill>
+                  <a:srgbClr val="545454"/>
+                </a:solidFill>
+                <a:latin typeface="Garet"/>
+                <a:ea typeface="Garet"/>
+                <a:cs typeface="Garet"/>
+                <a:sym typeface="Garet"/>
+              </a:rPr>
+              <a:t>Option to upload document in “Submit Claim” page</a:t>
+            </a:r>
+          </a:p>
+          <a:p>
+            <a:pPr algn="l">
+              <a:lnSpc>
+                <a:spcPts val="4576"/>
+              </a:lnSpc>
+            </a:pPr>
+            <a:endParaRPr lang="en-US" sz="3268">
+              <a:solidFill>
+                <a:srgbClr val="545454"/>
+              </a:solidFill>
+              <a:latin typeface="Garet"/>
+              <a:ea typeface="Garet"/>
+              <a:cs typeface="Garet"/>
+              <a:sym typeface="Garet"/>
+            </a:endParaRPr>
+          </a:p>
+        </p:txBody>
+      </p:sp>
+      <p:sp>
+        <p:nvSpPr>
+          <p:cNvPr id="9" name="TextBox 9"/>
+          <p:cNvSpPr txBox="1"/>
+          <p:nvPr/>
+        </p:nvSpPr>
+        <p:spPr>
+          <a:xfrm>
+            <a:off x="16214256" y="9019603"/>
+            <a:ext cx="1271574" cy="817275"/>
+          </a:xfrm>
+          <a:prstGeom prst="rect">
+            <a:avLst/>
+          </a:prstGeom>
+        </p:spPr>
+        <p:txBody>
+          <a:bodyPr lIns="0" tIns="0" rIns="0" bIns="0" rtlCol="0" anchor="t">
+            <a:spAutoFit/>
+          </a:bodyPr>
+          <a:lstStyle/>
+          <a:p>
+            <a:pPr algn="ctr">
+              <a:lnSpc>
+                <a:spcPts val="6641"/>
+              </a:lnSpc>
+              <a:spcBef>
+                <a:spcPct val="0"/>
+              </a:spcBef>
+            </a:pPr>
+            <a:r>
+              <a:rPr lang="en-US" sz="4743" b="1" dirty="0">
+                <a:solidFill>
+                  <a:srgbClr val="545454"/>
+                </a:solidFill>
+                <a:latin typeface="Garet Bold"/>
+                <a:ea typeface="Garet Bold"/>
+                <a:cs typeface="Garet Bold"/>
+                <a:sym typeface="Garet Bold"/>
+              </a:rPr>
+              <a:t>19</a:t>
+            </a:r>
+          </a:p>
+        </p:txBody>
+      </p:sp>
+    </p:spTree>
+  </p:cSld>
+  <p:clrMapOvr>
+    <a:masterClrMapping/>
+  </p:clrMapOvr>
+</p:sld>
+</file>
+
+<file path=ppt/slides/slide21.xml><?xml version="1.0" encoding="utf-8"?>
+<p:sld xmlns:a="http://schemas.openxmlformats.org/drawingml/2006/main" xmlns:r="http://schemas.openxmlformats.org/officeDocument/2006/relationships" xmlns:p="http://schemas.openxmlformats.org/presentationml/2006/main">
+  <p:cSld>
+    <p:bg>
+      <p:bgPr>
+        <a:solidFill>
+          <a:srgbClr val="E9E9E9"/>
+        </a:solidFill>
+        <a:effectLst/>
+      </p:bgPr>
+    </p:bg>
+    <p:spTree>
+      <p:nvGrpSpPr>
+        <p:cNvPr id="1" name=""/>
+        <p:cNvGrpSpPr/>
+        <p:nvPr/>
+      </p:nvGrpSpPr>
+      <p:grpSpPr>
+        <a:xfrm>
+          <a:off x="0" y="0"/>
+          <a:ext cx="0" cy="0"/>
+          <a:chOff x="0" y="0"/>
+          <a:chExt cx="0" cy="0"/>
+        </a:xfrm>
+      </p:grpSpPr>
+      <p:sp>
+        <p:nvSpPr>
+          <p:cNvPr id="2" name="Freeform 2"/>
+          <p:cNvSpPr/>
+          <p:nvPr/>
+        </p:nvSpPr>
+        <p:spPr>
+          <a:xfrm rot="5400000">
+            <a:off x="-598671" y="-1743170"/>
+            <a:ext cx="4840370" cy="6758253"/>
+          </a:xfrm>
+          <a:custGeom>
+            <a:avLst/>
+            <a:gdLst/>
+            <a:ahLst/>
+            <a:cxnLst/>
+            <a:rect l="l" t="t" r="r" b="b"/>
+            <a:pathLst>
+              <a:path w="4840370" h="6758253">
+                <a:moveTo>
+                  <a:pt x="0" y="0"/>
+                </a:moveTo>
+                <a:lnTo>
+                  <a:pt x="4840370" y="0"/>
+                </a:lnTo>
+                <a:lnTo>
+                  <a:pt x="4840370" y="6758253"/>
+                </a:lnTo>
+                <a:lnTo>
+                  <a:pt x="0" y="6758253"/>
+                </a:lnTo>
+                <a:lnTo>
+                  <a:pt x="0" y="0"/>
+                </a:lnTo>
+                <a:close/>
+              </a:path>
+            </a:pathLst>
+          </a:custGeom>
+          <a:blipFill>
+            <a:blip r:embed="rId2">
+              <a:extLst>
+                <a:ext uri="{96DAC541-7B7A-43D3-8B79-37D633B846F1}">
+                  <asvg:svgBlip xmlns:asvg="http://schemas.microsoft.com/office/drawing/2016/SVG/main" r:embed="rId3"/>
+                </a:ext>
+              </a:extLst>
+            </a:blip>
+            <a:stretch>
+              <a:fillRect/>
+            </a:stretch>
+          </a:blipFill>
+        </p:spPr>
+        <p:txBody>
+          <a:bodyPr/>
+          <a:lstStyle/>
+          <a:p>
+            <a:endParaRPr lang="en-GB"/>
+          </a:p>
+        </p:txBody>
+      </p:sp>
+      <p:sp>
+        <p:nvSpPr>
+          <p:cNvPr id="3" name="TextBox 3"/>
+          <p:cNvSpPr txBox="1"/>
+          <p:nvPr/>
+        </p:nvSpPr>
+        <p:spPr>
+          <a:xfrm>
+            <a:off x="4541415" y="1000865"/>
+            <a:ext cx="9205169" cy="1392492"/>
+          </a:xfrm>
+          <a:prstGeom prst="rect">
+            <a:avLst/>
+          </a:prstGeom>
+        </p:spPr>
+        <p:txBody>
+          <a:bodyPr lIns="0" tIns="0" rIns="0" bIns="0" rtlCol="0" anchor="t">
+            <a:spAutoFit/>
+          </a:bodyPr>
+          <a:lstStyle/>
+          <a:p>
+            <a:pPr algn="ctr">
+              <a:lnSpc>
+                <a:spcPts val="11448"/>
+              </a:lnSpc>
+            </a:pPr>
+            <a:r>
+              <a:rPr lang="en-US" sz="8177" b="1">
+                <a:solidFill>
+                  <a:srgbClr val="3F3D3E"/>
+                </a:solidFill>
+                <a:latin typeface="Alexandria Bold"/>
+                <a:ea typeface="Alexandria Bold"/>
+                <a:cs typeface="Alexandria Bold"/>
+                <a:sym typeface="Alexandria Bold"/>
+              </a:rPr>
+              <a:t>CONCLUSION</a:t>
+            </a:r>
+          </a:p>
+        </p:txBody>
+      </p:sp>
+      <p:sp>
+        <p:nvSpPr>
+          <p:cNvPr id="4" name="TextBox 4"/>
+          <p:cNvSpPr txBox="1"/>
+          <p:nvPr/>
+        </p:nvSpPr>
+        <p:spPr>
+          <a:xfrm>
+            <a:off x="3728730" y="3867640"/>
+            <a:ext cx="11400286" cy="4631846"/>
+          </a:xfrm>
+          <a:prstGeom prst="rect">
+            <a:avLst/>
+          </a:prstGeom>
+        </p:spPr>
+        <p:txBody>
+          <a:bodyPr lIns="0" tIns="0" rIns="0" bIns="0" rtlCol="0" anchor="t">
+            <a:spAutoFit/>
+          </a:bodyPr>
+          <a:lstStyle/>
+          <a:p>
+            <a:pPr marL="705747" lvl="1" indent="-352873" algn="l">
+              <a:lnSpc>
+                <a:spcPts val="4576"/>
+              </a:lnSpc>
+              <a:buFont typeface="Arial"/>
+              <a:buChar char="•"/>
+            </a:pPr>
+            <a:r>
+              <a:rPr lang="en-US" sz="3268">
+                <a:solidFill>
+                  <a:srgbClr val="545454"/>
+                </a:solidFill>
+                <a:latin typeface="Garet"/>
+                <a:ea typeface="Garet"/>
+                <a:cs typeface="Garet"/>
+                <a:sym typeface="Garet"/>
+              </a:rPr>
+              <a:t>CMCS improves accuracy and reduces manual admin</a:t>
+            </a:r>
+          </a:p>
+          <a:p>
+            <a:pPr marL="705747" lvl="1" indent="-352873" algn="l">
+              <a:lnSpc>
+                <a:spcPts val="4576"/>
+              </a:lnSpc>
+              <a:buFont typeface="Arial"/>
+              <a:buChar char="•"/>
+            </a:pPr>
+            <a:r>
+              <a:rPr lang="en-US" sz="3268">
+                <a:solidFill>
+                  <a:srgbClr val="545454"/>
+                </a:solidFill>
+                <a:latin typeface="Garet"/>
+                <a:ea typeface="Garet"/>
+                <a:cs typeface="Garet"/>
+                <a:sym typeface="Garet"/>
+              </a:rPr>
+              <a:t>Provides clear workflow between roles</a:t>
+            </a:r>
+          </a:p>
+          <a:p>
+            <a:pPr marL="705747" lvl="1" indent="-352873" algn="l">
+              <a:lnSpc>
+                <a:spcPts val="4576"/>
+              </a:lnSpc>
+              <a:buFont typeface="Arial"/>
+              <a:buChar char="•"/>
+            </a:pPr>
+            <a:r>
+              <a:rPr lang="en-US" sz="3268">
+                <a:solidFill>
+                  <a:srgbClr val="545454"/>
+                </a:solidFill>
+                <a:latin typeface="Garet"/>
+                <a:ea typeface="Garet"/>
+                <a:cs typeface="Garet"/>
+                <a:sym typeface="Garet"/>
+              </a:rPr>
+              <a:t>Secure, user-friendly and database-driven system</a:t>
+            </a:r>
+          </a:p>
+          <a:p>
+            <a:pPr marL="705747" lvl="1" indent="-352873" algn="l">
+              <a:lnSpc>
+                <a:spcPts val="4576"/>
+              </a:lnSpc>
+              <a:buFont typeface="Arial"/>
+              <a:buChar char="•"/>
+            </a:pPr>
+            <a:r>
+              <a:rPr lang="en-US" sz="3268">
+                <a:solidFill>
+                  <a:srgbClr val="545454"/>
+                </a:solidFill>
+                <a:latin typeface="Garet"/>
+                <a:ea typeface="Garet"/>
+                <a:cs typeface="Garet"/>
+                <a:sym typeface="Garet"/>
+              </a:rPr>
+              <a:t>Meets all automation, validation, and reporting requirements</a:t>
+            </a:r>
+          </a:p>
+          <a:p>
+            <a:pPr algn="ctr">
+              <a:lnSpc>
+                <a:spcPts val="4576"/>
+              </a:lnSpc>
+              <a:spcBef>
+                <a:spcPct val="0"/>
+              </a:spcBef>
+            </a:pPr>
+            <a:endParaRPr lang="en-US" sz="3268">
+              <a:solidFill>
+                <a:srgbClr val="545454"/>
+              </a:solidFill>
+              <a:latin typeface="Garet"/>
+              <a:ea typeface="Garet"/>
+              <a:cs typeface="Garet"/>
+              <a:sym typeface="Garet"/>
+            </a:endParaRPr>
+          </a:p>
+        </p:txBody>
+      </p:sp>
+      <p:sp>
+        <p:nvSpPr>
+          <p:cNvPr id="5" name="Freeform 5"/>
+          <p:cNvSpPr/>
+          <p:nvPr/>
+        </p:nvSpPr>
+        <p:spPr>
+          <a:xfrm rot="-574333">
+            <a:off x="-598671" y="5498906"/>
+            <a:ext cx="4840370" cy="6758253"/>
+          </a:xfrm>
+          <a:custGeom>
+            <a:avLst/>
+            <a:gdLst/>
+            <a:ahLst/>
+            <a:cxnLst/>
+            <a:rect l="l" t="t" r="r" b="b"/>
+            <a:pathLst>
+              <a:path w="4840370" h="6758253">
+                <a:moveTo>
+                  <a:pt x="0" y="0"/>
+                </a:moveTo>
+                <a:lnTo>
+                  <a:pt x="4840370" y="0"/>
+                </a:lnTo>
+                <a:lnTo>
+                  <a:pt x="4840370" y="6758253"/>
+                </a:lnTo>
+                <a:lnTo>
+                  <a:pt x="0" y="6758253"/>
+                </a:lnTo>
+                <a:lnTo>
+                  <a:pt x="0" y="0"/>
+                </a:lnTo>
+                <a:close/>
+              </a:path>
+            </a:pathLst>
+          </a:custGeom>
+          <a:blipFill>
+            <a:blip r:embed="rId4">
+              <a:extLst>
+                <a:ext uri="{96DAC541-7B7A-43D3-8B79-37D633B846F1}">
+                  <asvg:svgBlip xmlns:asvg="http://schemas.microsoft.com/office/drawing/2016/SVG/main" r:embed="rId5"/>
+                </a:ext>
+              </a:extLst>
+            </a:blip>
+            <a:stretch>
+              <a:fillRect/>
+            </a:stretch>
+          </a:blipFill>
+        </p:spPr>
+        <p:txBody>
+          <a:bodyPr/>
+          <a:lstStyle/>
+          <a:p>
+            <a:endParaRPr lang="en-GB"/>
+          </a:p>
+        </p:txBody>
+      </p:sp>
+      <p:sp>
+        <p:nvSpPr>
+          <p:cNvPr id="6" name="AutoShape 6"/>
+          <p:cNvSpPr/>
+          <p:nvPr/>
+        </p:nvSpPr>
+        <p:spPr>
+          <a:xfrm>
+            <a:off x="4541415" y="9464180"/>
+            <a:ext cx="11672841" cy="0"/>
+          </a:xfrm>
+          <a:prstGeom prst="line">
+            <a:avLst/>
+          </a:prstGeom>
+          <a:ln w="9525" cap="flat">
+            <a:solidFill>
+              <a:srgbClr val="545454"/>
+            </a:solidFill>
+            <a:prstDash val="solid"/>
+            <a:headEnd type="none" w="sm" len="sm"/>
+            <a:tailEnd type="none" w="sm" len="sm"/>
+          </a:ln>
+        </p:spPr>
+        <p:txBody>
+          <a:bodyPr/>
+          <a:lstStyle/>
+          <a:p>
+            <a:endParaRPr lang="en-GB"/>
+          </a:p>
+        </p:txBody>
+      </p:sp>
+      <p:sp>
+        <p:nvSpPr>
+          <p:cNvPr id="7" name="TextBox 7"/>
+          <p:cNvSpPr txBox="1"/>
+          <p:nvPr/>
+        </p:nvSpPr>
+        <p:spPr>
+          <a:xfrm>
+            <a:off x="16214256" y="9019603"/>
+            <a:ext cx="1271574" cy="817275"/>
+          </a:xfrm>
+          <a:prstGeom prst="rect">
+            <a:avLst/>
+          </a:prstGeom>
+        </p:spPr>
+        <p:txBody>
+          <a:bodyPr lIns="0" tIns="0" rIns="0" bIns="0" rtlCol="0" anchor="t">
+            <a:spAutoFit/>
+          </a:bodyPr>
+          <a:lstStyle/>
+          <a:p>
+            <a:pPr algn="ctr">
+              <a:lnSpc>
+                <a:spcPts val="6641"/>
+              </a:lnSpc>
+              <a:spcBef>
+                <a:spcPct val="0"/>
+              </a:spcBef>
+            </a:pPr>
+            <a:r>
+              <a:rPr lang="en-US" sz="4743" b="1" dirty="0">
+                <a:solidFill>
+                  <a:srgbClr val="545454"/>
+                </a:solidFill>
+                <a:latin typeface="Garet Bold"/>
+                <a:ea typeface="Garet Bold"/>
+                <a:cs typeface="Garet Bold"/>
+                <a:sym typeface="Garet Bold"/>
+              </a:rPr>
+              <a:t>20</a:t>
+            </a:r>
+          </a:p>
+        </p:txBody>
+      </p:sp>
+    </p:spTree>
+  </p:cSld>
+  <p:clrMapOvr>
+    <a:masterClrMapping/>
+  </p:clrMapOvr>
+</p:sld>
+</file>
+
+<file path=ppt/slides/slide22.xml><?xml version="1.0" encoding="utf-8"?>
+<p:sld xmlns:a="http://schemas.openxmlformats.org/drawingml/2006/main" xmlns:r="http://schemas.openxmlformats.org/officeDocument/2006/relationships" xmlns:p="http://schemas.openxmlformats.org/presentationml/2006/main">
+  <p:cSld>
+    <p:bg>
+      <p:bgPr>
+        <a:solidFill>
+          <a:srgbClr val="E9E9E9"/>
+        </a:solidFill>
+        <a:effectLst/>
+      </p:bgPr>
+    </p:bg>
+    <p:spTree>
+      <p:nvGrpSpPr>
+        <p:cNvPr id="1" name=""/>
+        <p:cNvGrpSpPr/>
+        <p:nvPr/>
+      </p:nvGrpSpPr>
+      <p:grpSpPr>
+        <a:xfrm>
+          <a:off x="0" y="0"/>
+          <a:ext cx="0" cy="0"/>
+          <a:chOff x="0" y="0"/>
+          <a:chExt cx="0" cy="0"/>
+        </a:xfrm>
+      </p:grpSpPr>
+      <p:sp>
+        <p:nvSpPr>
+          <p:cNvPr id="2" name="Freeform 2"/>
+          <p:cNvSpPr/>
+          <p:nvPr/>
+        </p:nvSpPr>
+        <p:spPr>
+          <a:xfrm rot="5400000">
+            <a:off x="-598671" y="-1743170"/>
+            <a:ext cx="4840370" cy="6758253"/>
+          </a:xfrm>
+          <a:custGeom>
+            <a:avLst/>
+            <a:gdLst/>
+            <a:ahLst/>
+            <a:cxnLst/>
+            <a:rect l="l" t="t" r="r" b="b"/>
+            <a:pathLst>
+              <a:path w="4840370" h="6758253">
+                <a:moveTo>
+                  <a:pt x="0" y="0"/>
+                </a:moveTo>
+                <a:lnTo>
+                  <a:pt x="4840370" y="0"/>
+                </a:lnTo>
+                <a:lnTo>
+                  <a:pt x="4840370" y="6758253"/>
+                </a:lnTo>
+                <a:lnTo>
+                  <a:pt x="0" y="6758253"/>
+                </a:lnTo>
+                <a:lnTo>
+                  <a:pt x="0" y="0"/>
+                </a:lnTo>
+                <a:close/>
+              </a:path>
+            </a:pathLst>
+          </a:custGeom>
+          <a:blipFill>
+            <a:blip r:embed="rId2">
+              <a:extLst>
+                <a:ext uri="{96DAC541-7B7A-43D3-8B79-37D633B846F1}">
+                  <asvg:svgBlip xmlns:asvg="http://schemas.microsoft.com/office/drawing/2016/SVG/main" r:embed="rId3"/>
+                </a:ext>
+              </a:extLst>
+            </a:blip>
+            <a:stretch>
+              <a:fillRect/>
+            </a:stretch>
+          </a:blipFill>
+        </p:spPr>
+        <p:txBody>
+          <a:bodyPr/>
+          <a:lstStyle/>
+          <a:p>
+            <a:endParaRPr lang="en-GB"/>
+          </a:p>
+        </p:txBody>
+      </p:sp>
+      <p:sp>
+        <p:nvSpPr>
+          <p:cNvPr id="3" name="TextBox 3"/>
+          <p:cNvSpPr txBox="1"/>
+          <p:nvPr/>
+        </p:nvSpPr>
+        <p:spPr>
+          <a:xfrm>
+            <a:off x="2668325" y="4041844"/>
+            <a:ext cx="12951349" cy="1974712"/>
+          </a:xfrm>
+          <a:prstGeom prst="rect">
+            <a:avLst/>
+          </a:prstGeom>
+        </p:spPr>
+        <p:txBody>
+          <a:bodyPr lIns="0" tIns="0" rIns="0" bIns="0" rtlCol="0" anchor="t">
+            <a:spAutoFit/>
+          </a:bodyPr>
+          <a:lstStyle/>
+          <a:p>
+            <a:pPr algn="ctr">
+              <a:lnSpc>
+                <a:spcPts val="16107"/>
+              </a:lnSpc>
+            </a:pPr>
+            <a:r>
+              <a:rPr lang="en-US" sz="11505" b="1">
+                <a:solidFill>
+                  <a:srgbClr val="3F3D3E"/>
+                </a:solidFill>
+                <a:latin typeface="Alexandria Bold"/>
+                <a:ea typeface="Alexandria Bold"/>
+                <a:cs typeface="Alexandria Bold"/>
+                <a:sym typeface="Alexandria Bold"/>
+              </a:rPr>
+              <a:t>THANK YOU</a:t>
+            </a:r>
+          </a:p>
+        </p:txBody>
+      </p:sp>
+      <p:sp>
+        <p:nvSpPr>
+          <p:cNvPr id="4" name="Freeform 4"/>
+          <p:cNvSpPr/>
+          <p:nvPr/>
+        </p:nvSpPr>
+        <p:spPr>
+          <a:xfrm rot="-574333">
+            <a:off x="-598671" y="5498906"/>
+            <a:ext cx="4840370" cy="6758253"/>
+          </a:xfrm>
+          <a:custGeom>
+            <a:avLst/>
+            <a:gdLst/>
+            <a:ahLst/>
+            <a:cxnLst/>
+            <a:rect l="l" t="t" r="r" b="b"/>
+            <a:pathLst>
+              <a:path w="4840370" h="6758253">
+                <a:moveTo>
+                  <a:pt x="0" y="0"/>
+                </a:moveTo>
+                <a:lnTo>
+                  <a:pt x="4840370" y="0"/>
+                </a:lnTo>
+                <a:lnTo>
+                  <a:pt x="4840370" y="6758253"/>
+                </a:lnTo>
+                <a:lnTo>
+                  <a:pt x="0" y="6758253"/>
+                </a:lnTo>
+                <a:lnTo>
+                  <a:pt x="0" y="0"/>
+                </a:lnTo>
+                <a:close/>
+              </a:path>
+            </a:pathLst>
+          </a:custGeom>
+          <a:blipFill>
+            <a:blip r:embed="rId4">
+              <a:extLst>
+                <a:ext uri="{96DAC541-7B7A-43D3-8B79-37D633B846F1}">
+                  <asvg:svgBlip xmlns:asvg="http://schemas.microsoft.com/office/drawing/2016/SVG/main" r:embed="rId5"/>
+                </a:ext>
+              </a:extLst>
+            </a:blip>
+            <a:stretch>
+              <a:fillRect/>
+            </a:stretch>
+          </a:blipFill>
+        </p:spPr>
+        <p:txBody>
+          <a:bodyPr/>
+          <a:lstStyle/>
+          <a:p>
+            <a:endParaRPr lang="en-GB"/>
+          </a:p>
+        </p:txBody>
+      </p:sp>
+      <p:sp>
+        <p:nvSpPr>
+          <p:cNvPr id="5" name="AutoShape 5"/>
+          <p:cNvSpPr/>
+          <p:nvPr/>
+        </p:nvSpPr>
+        <p:spPr>
+          <a:xfrm>
+            <a:off x="4541415" y="9464180"/>
+            <a:ext cx="11672841" cy="0"/>
+          </a:xfrm>
+          <a:prstGeom prst="line">
+            <a:avLst/>
+          </a:prstGeom>
+          <a:ln w="9525" cap="flat">
+            <a:solidFill>
+              <a:srgbClr val="545454"/>
+            </a:solidFill>
+            <a:prstDash val="solid"/>
+            <a:headEnd type="none" w="sm" len="sm"/>
+            <a:tailEnd type="none" w="sm" len="sm"/>
+          </a:ln>
+        </p:spPr>
+        <p:txBody>
+          <a:bodyPr/>
+          <a:lstStyle/>
+          <a:p>
+            <a:endParaRPr lang="en-GB"/>
+          </a:p>
+        </p:txBody>
+      </p:sp>
+      <p:sp>
+        <p:nvSpPr>
           <p:cNvPr id="6" name="TextBox 6"/>
           <p:cNvSpPr txBox="1"/>
           <p:nvPr/>
@@ -8363,7 +9161,7 @@
         <p:spPr>
           <a:xfrm>
             <a:off x="16214256" y="9019603"/>
-            <a:ext cx="1271574" cy="803430"/>
+            <a:ext cx="1271574" cy="817275"/>
           </a:xfrm>
           <a:prstGeom prst="rect">
             <a:avLst/>
@@ -8393,7 +9191,7 @@
                 <a:cs typeface="Garet Bold"/>
                 <a:sym typeface="Garet Bold"/>
               </a:rPr>
-              <a:t>19</a:t>
+              <a:t>21</a:t>
             </a:r>
           </a:p>
         </p:txBody>

</xml_diff>